<commit_message>
docs: actualizar PPT y benja.md - ingesta-ms3 completo, 5/5 queries Athena
</commit_message>
<xml_diff>
--- a/ppt/hito2-resumen.pptx
+++ b/ppt/hito2-resumen.pptx
@@ -3835,7 +3835,7 @@
               </a:defRPr>
             </a:pPr>
             <a:r>
-              <a:t>• 3 contenedores de ingesta: ingesta-ms1 (Guillermo), ingesta-ms2 (Mariano), ingesta-ms3 (Edinson, pendiente)</a:t>
+              <a:t>• 3 contenedores de ingesta: ingesta-ms1 (Guillermo), ingesta-ms2 (Mariano), ingesta-ms3 (aplanado de Fabricio, conectado hoy)</a:t>
             </a:r>
           </a:p>
           <a:p>
@@ -3850,7 +3850,7 @@
               </a:defRPr>
             </a:pPr>
             <a:r>
-              <a:t>   – Desplegados y corridos de verdad en VM-INGESTA el 22/23-Set contra la VM-DB real</a:t>
+              <a:t>   – Los 3 desplegados y corridos de verdad en VM-INGESTA contra la VM-DB real</a:t>
             </a:r>
           </a:p>
           <a:p>
@@ -3865,7 +3865,7 @@
               </a:defRPr>
             </a:pPr>
             <a:r>
-              <a:t>• raw/ms1/ y raw/ms2/ en S3 con datos reales (184k+ y 20.5k+ filas respectivamente)</a:t>
+              <a:t>• raw/ms1/, raw/ms2/ y raw/ms3/ en S3 con datos reales de las 3 fuentes — pull 100%</a:t>
             </a:r>
           </a:p>
           <a:p>
@@ -3880,7 +3880,7 @@
               </a:defRPr>
             </a:pPr>
             <a:r>
-              <a:t>• raw/ms3/ pendiente — sin seed ni ingesta todavía</a:t>
+              <a:t>• ingesta-ms3 aplana incidencias.afecta_recursos[]/retrasa_vuelos[] a 2 tablas relacionales</a:t>
             </a:r>
           </a:p>
         </p:txBody>
@@ -4049,7 +4049,22 @@
               </a:defRPr>
             </a:pPr>
             <a:r>
-              <a:t>• Catálogo Glue aeropuerto_lake: crawlers por prefijo raw/ms1, ms2, ms3</a:t>
+              <a:t>• Catálogo Glue aeropuerto_lake: 1 crawler por prefijo, 19 tablas catalogadas (las 3 fuentes completas)</a:t>
+            </a:r>
+          </a:p>
+          <a:p>
+            <a:pPr>
+              <a:spcAft>
+                <a:spcPts val="1000"/>
+              </a:spcAft>
+              <a:defRPr sz="1800">
+                <a:solidFill>
+                  <a:srgbClr val="1A1A2E"/>
+                </a:solidFill>
+              </a:defRPr>
+            </a:pPr>
+            <a:r>
+              <a:t>• 5 de 5 consultas de negocio (Q1–Q5) con JOIN + 2 de 2 vistas — todas corriendo con datos reales</a:t>
             </a:r>
           </a:p>
           <a:p>
@@ -4064,7 +4079,7 @@
               </a:defRPr>
             </a:pPr>
             <a:r>
-              <a:t>   – ms2: 8 tablas catalogadas (aerolinea, aeronave, asiento, empleado, vuelo, tripulacion, opera_tripulacion, operativo_tierra)</a:t>
+              <a:t>   – Bug encontrado y arreglado: timestamps ISO8601 mal inferidos por el crawler (DS-10) + comas sin escapar rompiendo columnas</a:t>
             </a:r>
           </a:p>
           <a:p>
@@ -4079,22 +4094,7 @@
               </a:defRPr>
             </a:pPr>
             <a:r>
-              <a:t>• 5 consultas de negocio (Q1–Q5) con JOIN + 2 vistas (recaudación TUUA, retrasos hora punta) listas en Athena</a:t>
-            </a:r>
-          </a:p>
-          <a:p>
-            <a:pPr>
-              <a:spcAft>
-                <a:spcPts val="1000"/>
-              </a:spcAft>
-              <a:defRPr sz="1800">
-                <a:solidFill>
-                  <a:srgbClr val="1A1A2E"/>
-                </a:solidFill>
-              </a:defRPr>
-            </a:pPr>
-            <a:r>
-              <a:t>• E/R del catálogo: 19 tablas propuestas de 3 fuentes (borrador de Fabricio, revisión cruzada pendiente)</a:t>
+              <a:t>• E/R del catálogo: 19 tablas de 3 fuentes (borrador de Fabricio, revisión cruzada DA-04 pendiente)</a:t>
             </a:r>
           </a:p>
         </p:txBody>
@@ -4926,7 +4926,7 @@
               </a:defRPr>
             </a:pPr>
             <a:r>
-              <a:t>• Completo con evidencia real: infra desplegada, API Gateway público, MS1+MS2 con carga masiva e ingesta a S3, catálogo Glue de MS2, MS3→MS2 verificado</a:t>
+              <a:t>• Completo con evidencia real: infra desplegada, API Gateway público, 3 BD con carga masiva ≥20k, 3 contenedores de ingesta, MS3→MS2 verificado</a:t>
             </a:r>
           </a:p>
           <a:p>
@@ -4941,7 +4941,7 @@
               </a:defRPr>
             </a:pPr>
             <a:r>
-              <a:t>• Contingencias aplicadas: Docker Hub en vez de GHCR · bucket S3 gestionado por CLI · despliegue en cuenta AWS de respaldo</a:t>
+              <a:t>• Pipeline de datos completo: MySQL/PostgreSQL/MongoDB → S3 → Glue (19 tablas) → Athena (5 queries + 2 vistas, todo con datos reales)</a:t>
             </a:r>
           </a:p>
           <a:p>
@@ -4956,7 +4956,22 @@
               </a:defRPr>
             </a:pPr>
             <a:r>
-              <a:t>• Pendiente: ingesta-ms3 (Edinson) · confirmación de Amplify o contingencia S3+CloudFront · consultas Athena finales · consolidación del informe</a:t>
+              <a:t>• Contingencias aplicadas: Docker Hub en vez de GHCR · bucket S3 gestionado por CLI · despliegue en cuenta AWS de respaldo</a:t>
+            </a:r>
+          </a:p>
+          <a:p>
+            <a:pPr>
+              <a:spcAft>
+                <a:spcPts val="1000"/>
+              </a:spcAft>
+              <a:defRPr sz="1800">
+                <a:solidFill>
+                  <a:srgbClr val="1A1A2E"/>
+                </a:solidFill>
+              </a:defRPr>
+            </a:pPr>
+            <a:r>
+              <a:t>• Pendiente: confirmación de Amplify o contingencia S3+CloudFront · consolidación final del informe (secciones de cada quien) · ensayo de demo</a:t>
             </a:r>
           </a:p>
           <a:p>
@@ -6983,6 +6998,21 @@
             </a:r>
           </a:p>
           <a:p>
+            <a:pPr>
+              <a:spcAft>
+                <a:spcPts val="1000"/>
+              </a:spcAft>
+              <a:defRPr sz="1800">
+                <a:solidFill>
+                  <a:srgbClr val="1A1A2E"/>
+                </a:solidFill>
+              </a:defRPr>
+            </a:pPr>
+            <a:r>
+              <a:t>• MongoDB (MS3) — incidencias: 25 000 documentos (500 recursos, 40 000 asignaciones)</a:t>
+            </a:r>
+          </a:p>
+          <a:p>
             <a:pPr lvl="1">
               <a:spcAft>
                 <a:spcPts val="400"/>
@@ -6994,22 +7024,7 @@
               </a:defRPr>
             </a:pPr>
             <a:r>
-              <a:t>   – Verificado con COUNT(*) independiente contra la BD real en producción, 23-Set-2026</a:t>
-            </a:r>
-          </a:p>
-          <a:p>
-            <a:pPr>
-              <a:spcAft>
-                <a:spcPts val="1000"/>
-              </a:spcAft>
-              <a:defRPr sz="1800">
-                <a:solidFill>
-                  <a:srgbClr val="1A1A2E"/>
-                </a:solidFill>
-              </a:defRPr>
-            </a:pPr>
-            <a:r>
-              <a:t>• MongoDB (MS3) — incidencias: pendiente, bloqueado por falta de seed/ingesta</a:t>
+              <a:t>   – Las 3 BD verificadas con COUNT(*)/countDocuments() independiente, 23-Set-2026</a:t>
             </a:r>
           </a:p>
         </p:txBody>

</xml_diff>